<commit_message>
Change 2: Department HQ, not department / office / RM
The 28 August note on the site table row now reads that the narrowing
to Department HQ applies to all the same columns, and the descriptions
were rewritten accordingly. Six places in the deck still grouped by
department, office or RM. Slide 12's Department row also moves from an
open proposal to confirmed, since that question is now answered.

Co-Authored-By: Claude Opus 5 <noreply@anthropic.com>
Claude-Session: https://claude.ai/code/session_01VdkbQVuogqce5Eq5woYD3Q
</commit_message>
<xml_diff>
--- a/EDRMS_Util_Report_3.pptx
+++ b/EDRMS_Util_Report_3.pptx
@@ -11869,7 +11869,7 @@
                           <a:ea typeface="Calibri" pitchFamily="34" charset="-122"/>
                           <a:cs typeface="Calibri" pitchFamily="34" charset="-120"/>
                         </a:rPr>
-                        <a:t>Two levels: department, then division. Countries, RMs and offices are divisions.</a:t>
+                        <a:t>Confirmed 28 August: Department HQ, then division. Countries, RMs and offices are divisions.</a:t>
                       </a:r>
                       <a:endParaRPr lang="en-US" sz="1000" dirty="0">
                         <a:latin typeface="Calibri" charset="0"/>
@@ -12713,7 +12713,7 @@
                           <a:ea typeface="Calibri" pitchFamily="34" charset="-122"/>
                           <a:cs typeface="Calibri" pitchFamily="34" charset="-120"/>
                         </a:rPr>
-                        <a:t>We read it as the department, office or RM on that row.</a:t>
+                        <a:t>We read it as the department on that row.</a:t>
                       </a:r>
                       <a:endParaRPr lang="en-US" sz="1000" dirty="0">
                         <a:latin typeface="Calibri" charset="0"/>
@@ -21449,7 +21449,7 @@
                 <a:ea typeface="Calibri" pitchFamily="34" charset="-122"/>
                 <a:cs typeface="Calibri" pitchFamily="34" charset="-120"/>
               </a:rPr>
-              <a:t>Every department, office and RM with its sites, documents, records and counterparts.</a:t>
+              <a:t>Every department with its sites, documents, records and counterparts.</a:t>
             </a:r>
             <a:endParaRPr lang="en-US" sz="950" dirty="0"/>
           </a:p>
@@ -22740,7 +22740,7 @@
                           <a:ea typeface="Calibri" pitchFamily="34" charset="-122"/>
                           <a:cs typeface="Calibri" pitchFamily="34" charset="-120"/>
                         </a:rPr>
-                        <a:t>EDRMS sites, grouped by department, office or RM</a:t>
+                        <a:t>EDRMS sites, grouped by department HQ</a:t>
                       </a:r>
                       <a:endParaRPr lang="en-US" sz="1000" dirty="0">
                         <a:latin typeface="Calibri" charset="0"/>
@@ -25715,7 +25715,7 @@
                           <a:ea typeface="Calibri" pitchFamily="34" charset="-122"/>
                           <a:cs typeface="Calibri" pitchFamily="34" charset="-120"/>
                         </a:rPr>
-                        <a:t>The owning unit of each site</a:t>
+                        <a:t>The owning department. Narrowed to Department HQ on 28 August.</a:t>
                       </a:r>
                       <a:endParaRPr lang="en-US" sz="1000" dirty="0">
                         <a:latin typeface="Calibri" charset="0"/>
@@ -28517,7 +28517,7 @@
                 <a:ea typeface="Calibri" pitchFamily="34" charset="-122"/>
                 <a:cs typeface="Calibri" pitchFamily="34" charset="-120"/>
               </a:rPr>
-              <a:t>One unit's own view. Pick a department, office or RM and everything below refreshes for it.</a:t>
+              <a:t>One department's own view. Pick a department and everything below refreshes for it.</a:t>
             </a:r>
             <a:endParaRPr lang="en-US" sz="1300" dirty="0"/>
           </a:p>

</xml_diff>

<commit_message>
Change 3: physical counterpart, not paper counterpart
The sheets now say physical counterpart throughout. Three deck cells
still said paper.

Co-Authored-By: Claude Opus 5 <noreply@anthropic.com>
Claude-Session: https://claude.ai/code/session_01VdkbQVuogqce5Eq5woYD3Q
</commit_message>
<xml_diff>
--- a/EDRMS_Util_Report_3.pptx
+++ b/EDRMS_Util_Report_3.pptx
@@ -5942,7 +5942,7 @@
                           <a:ea typeface="Calibri" pitchFamily="34" charset="-122"/>
                           <a:cs typeface="Calibri" pitchFamily="34" charset="-120"/>
                         </a:rPr>
-                        <a:t>Declared records flagged as having a paper counterpart</a:t>
+                        <a:t>Declared records flagged as having a physical counterpart</a:t>
                       </a:r>
                       <a:endParaRPr lang="en-US" sz="1000" dirty="0">
                         <a:latin typeface="Calibri" charset="0"/>
@@ -8291,7 +8291,7 @@
                           <a:ea typeface="Calibri" pitchFamily="34" charset="-122"/>
                           <a:cs typeface="Calibri" pitchFamily="34" charset="-120"/>
                         </a:rPr>
-                        <a:t>Declared records and paper counterparts per site</a:t>
+                        <a:t>Declared records and physical counterparts per site</a:t>
                       </a:r>
                       <a:endParaRPr lang="en-US" sz="950" dirty="0">
                         <a:latin typeface="Calibri" charset="0"/>
@@ -23856,7 +23856,7 @@
                           <a:ea typeface="Calibri" pitchFamily="34" charset="-122"/>
                           <a:cs typeface="Calibri" pitchFamily="34" charset="-120"/>
                         </a:rPr>
-                        <a:t>Declared records flagged as having a paper counterpart</a:t>
+                        <a:t>Declared records flagged as having a physical counterpart</a:t>
                       </a:r>
                       <a:endParaRPr lang="en-US" sz="1000" dirty="0">
                         <a:latin typeface="Calibri" charset="0"/>

</xml_diff>

<commit_message>
Change 4: the window and category pickers are gone
Quick Windows (7/30/90/180) and Filter by month/year were deleted from
Slide 56 Site Visits, and the category picker from library usage. The
7 to 180 day window itself still exists, so only the choose-it wording
goes; the file plan grouping stays because only the picker was removed.

Co-Authored-By: Claude Opus 5 <noreply@anthropic.com>
Claude-Session: https://claude.ai/code/session_01VdkbQVuogqce5Eq5woYD3Q
</commit_message>
<xml_diff>
--- a/EDRMS_Util_Report_3.pptx
+++ b/EDRMS_Util_Report_3.pptx
@@ -29162,7 +29162,7 @@
                 <a:ea typeface="Calibri" pitchFamily="34" charset="-122"/>
                 <a:cs typeface="Calibri" pitchFamily="34" charset="-120"/>
               </a:rPr>
-              <a:t>Page views and visited pages per site, over a window you choose.</a:t>
+              <a:t>Page views and visited pages per site, over the reporting window.</a:t>
             </a:r>
             <a:endParaRPr lang="en-US" sz="950" dirty="0"/>
           </a:p>
@@ -29377,7 +29377,7 @@
                 <a:ea typeface="Calibri" pitchFamily="34" charset="-122"/>
                 <a:cs typeface="Calibri" pitchFamily="34" charset="-120"/>
               </a:rPr>
-              <a:t>Libraries inside the unit's sites, grouped by file plan category.</a:t>
+              <a:t>Libraries inside the department's sites, grouped by file plan category.</a:t>
             </a:r>
             <a:endParaRPr lang="en-US" sz="950" dirty="0"/>
           </a:p>

</xml_diff>

<commit_message>
Change 5: department, not unit, in the running prose
Eight prose and table cells still said unit for the thing the picker
selects. Unit is the third level of the ADB hierarchy and the level the
report does not use. Slide 12's Unit row keeps the word because it
quotes the client's own review question.

Co-Authored-By: Claude Opus 5 <noreply@anthropic.com>
Claude-Session: https://claude.ai/code/session_01VdkbQVuogqce5Eq5woYD3Q
</commit_message>
<xml_diff>
--- a/EDRMS_Util_Report_3.pptx
+++ b/EDRMS_Util_Report_3.pptx
@@ -4547,7 +4547,7 @@
                           <a:ea typeface="Calibri" pitchFamily="34" charset="-122"/>
                           <a:cs typeface="Calibri" pitchFamily="34" charset="-120"/>
                         </a:rPr>
-                        <a:t>Sites provisioned to this unit</a:t>
+                        <a:t>Sites provisioned to this department</a:t>
                       </a:r>
                       <a:endParaRPr lang="en-US" sz="1000" dirty="0">
                         <a:latin typeface="Calibri" charset="0"/>
@@ -4826,7 +4826,7 @@
                           <a:ea typeface="Calibri" pitchFamily="34" charset="-122"/>
                           <a:cs typeface="Calibri" pitchFamily="34" charset="-120"/>
                         </a:rPr>
-                        <a:t>People with recorded activity for this unit</a:t>
+                        <a:t>People with recorded activity for this department</a:t>
                       </a:r>
                       <a:endParaRPr lang="en-US" sz="1000" dirty="0">
                         <a:latin typeface="Calibri" charset="0"/>
@@ -5384,7 +5384,7 @@
                           <a:ea typeface="Calibri" pitchFamily="34" charset="-122"/>
                           <a:cs typeface="Calibri" pitchFamily="34" charset="-120"/>
                         </a:rPr>
-                        <a:t>File count across the unit's sites</a:t>
+                        <a:t>File count across the department's sites</a:t>
                       </a:r>
                       <a:endParaRPr lang="en-US" sz="1000" dirty="0">
                         <a:latin typeface="Calibri" charset="0"/>
@@ -5663,7 +5663,7 @@
                           <a:ea typeface="Calibri" pitchFamily="34" charset="-122"/>
                           <a:cs typeface="Calibri" pitchFamily="34" charset="-120"/>
                         </a:rPr>
-                        <a:t>Declared records for the unit's sites</a:t>
+                        <a:t>Declared records for the department's sites</a:t>
                       </a:r>
                       <a:endParaRPr lang="en-US" sz="1000" dirty="0">
                         <a:latin typeface="Calibri" charset="0"/>
@@ -6500,7 +6500,7 @@
                           <a:ea typeface="Calibri" pitchFamily="34" charset="-122"/>
                           <a:cs typeface="Calibri" pitchFamily="34" charset="-120"/>
                         </a:rPr>
-                        <a:t>When the unit went live on EDRMS</a:t>
+                        <a:t>When the department went live on EDRMS</a:t>
                       </a:r>
                       <a:endParaRPr lang="en-US" sz="1000" dirty="0">
                         <a:latin typeface="Calibri" charset="0"/>
@@ -7733,7 +7733,7 @@
                           <a:ea typeface="Calibri" pitchFamily="34" charset="-122"/>
                           <a:cs typeface="Calibri" pitchFamily="34" charset="-120"/>
                         </a:rPr>
-                        <a:t>Each site the unit owns and who owns it</a:t>
+                        <a:t>Each site the department owns and who owns it</a:t>
                       </a:r>
                       <a:endParaRPr lang="en-US" sz="950" dirty="0">
                         <a:latin typeface="Calibri" charset="0"/>
@@ -28732,7 +28732,7 @@
                 <a:ea typeface="Calibri" pitchFamily="34" charset="-122"/>
                 <a:cs typeface="Calibri" pitchFamily="34" charset="-120"/>
               </a:rPr>
-              <a:t>Seven tiles for the selected unit, each opening its own table.</a:t>
+              <a:t>Seven tiles for the selected department, each opening its own table.</a:t>
             </a:r>
             <a:endParaRPr lang="en-US" sz="950" dirty="0"/>
           </a:p>
@@ -28947,7 +28947,7 @@
                 <a:ea typeface="Calibri" pitchFamily="34" charset="-122"/>
                 <a:cs typeface="Calibri" pitchFamily="34" charset="-120"/>
               </a:rPr>
-              <a:t>Every site the unit owns, with its owner, documents, records and counterparts.</a:t>
+              <a:t>Every site the department owns, with its owner, documents, records and counterparts.</a:t>
             </a:r>
             <a:endParaRPr lang="en-US" sz="950" dirty="0"/>
           </a:p>

</xml_diff>